<commit_message>
Actualiza presentacion de la Fase 1 con capturas de SSIS y nueva paleta
</commit_message>
<xml_diff>
--- a/docs/presentacion/presentacion-fase1-kentfoods.pptx
+++ b/docs/presentacion/presentacion-fase1-kentfoods.pptx
@@ -12314,7 +12314,7 @@
         </p:nvSpPr>
         <p:spPr>
           <a:xfrm>
-            <a:off x="819150" y="1912640"/>
+            <a:off x="819150" y="1760240"/>
             <a:ext cx="2899767" cy="1000720"/>
           </a:xfrm>
           <a:prstGeom prst="roundRect">
@@ -12341,7 +12341,7 @@
         </p:nvSpPr>
         <p:spPr>
           <a:xfrm>
-            <a:off x="1054100" y="2122190"/>
+            <a:off x="1054100" y="1969790"/>
             <a:ext cx="2502763" cy="330200"/>
           </a:xfrm>
           <a:prstGeom prst="rect">
@@ -12385,7 +12385,7 @@
         </p:nvSpPr>
         <p:spPr>
           <a:xfrm>
-            <a:off x="1054100" y="2490490"/>
+            <a:off x="1054100" y="2338090"/>
             <a:ext cx="2502763" cy="238720"/>
           </a:xfrm>
           <a:prstGeom prst="rect">
@@ -12436,7 +12436,7 @@
         </p:blipFill>
         <p:spPr>
           <a:xfrm>
-            <a:off x="3928467" y="2286000"/>
+            <a:off x="3928467" y="2133600"/>
             <a:ext cx="508000" cy="254000"/>
           </a:xfrm>
           <a:prstGeom prst="rect">
@@ -12452,7 +12452,7 @@
         </p:nvSpPr>
         <p:spPr>
           <a:xfrm>
-            <a:off x="4646017" y="1912640"/>
+            <a:off x="4646017" y="1760240"/>
             <a:ext cx="2899866" cy="1000720"/>
           </a:xfrm>
           <a:prstGeom prst="roundRect">
@@ -12479,7 +12479,7 @@
         </p:nvSpPr>
         <p:spPr>
           <a:xfrm>
-            <a:off x="4880967" y="2122190"/>
+            <a:off x="4880967" y="1969790"/>
             <a:ext cx="2502865" cy="330200"/>
           </a:xfrm>
           <a:prstGeom prst="rect">
@@ -12523,7 +12523,7 @@
         </p:nvSpPr>
         <p:spPr>
           <a:xfrm>
-            <a:off x="4880967" y="2490490"/>
+            <a:off x="4880967" y="2338090"/>
             <a:ext cx="2502865" cy="238720"/>
           </a:xfrm>
           <a:prstGeom prst="rect">
@@ -12574,7 +12574,7 @@
         </p:blipFill>
         <p:spPr>
           <a:xfrm>
-            <a:off x="7755434" y="2286000"/>
+            <a:off x="7755434" y="2133600"/>
             <a:ext cx="508000" cy="254000"/>
           </a:xfrm>
           <a:prstGeom prst="rect">
@@ -12590,7 +12590,7 @@
         </p:nvSpPr>
         <p:spPr>
           <a:xfrm>
-            <a:off x="8472984" y="1912640"/>
+            <a:off x="8472984" y="1760240"/>
             <a:ext cx="2899866" cy="1000720"/>
           </a:xfrm>
           <a:prstGeom prst="roundRect">
@@ -12617,7 +12617,7 @@
         </p:nvSpPr>
         <p:spPr>
           <a:xfrm>
-            <a:off x="8707934" y="2122190"/>
+            <a:off x="8707934" y="1969790"/>
             <a:ext cx="2502865" cy="330200"/>
           </a:xfrm>
           <a:prstGeom prst="rect">
@@ -12661,7 +12661,7 @@
         </p:nvSpPr>
         <p:spPr>
           <a:xfrm>
-            <a:off x="8707934" y="2490490"/>
+            <a:off x="8707934" y="2338090"/>
             <a:ext cx="2502865" cy="238720"/>
           </a:xfrm>
           <a:prstGeom prst="rect">
@@ -12705,7 +12705,7 @@
         </p:nvSpPr>
         <p:spPr>
           <a:xfrm>
-            <a:off x="812800" y="3905250"/>
+            <a:off x="812800" y="2990850"/>
             <a:ext cx="1054100" cy="419100"/>
           </a:xfrm>
           <a:prstGeom prst="roundRect">
@@ -12760,7 +12760,7 @@
         </p:blipFill>
         <p:spPr>
           <a:xfrm>
-            <a:off x="1990725" y="4064000"/>
+            <a:off x="1990725" y="3149600"/>
             <a:ext cx="177800" cy="101600"/>
           </a:xfrm>
           <a:prstGeom prst="rect">
@@ -12776,7 +12776,7 @@
         </p:nvSpPr>
         <p:spPr>
           <a:xfrm>
-            <a:off x="2295525" y="3902075"/>
+            <a:off x="2295525" y="2987675"/>
             <a:ext cx="1746250" cy="425450"/>
           </a:xfrm>
           <a:prstGeom prst="roundRect">
@@ -12834,7 +12834,7 @@
         </p:blipFill>
         <p:spPr>
           <a:xfrm>
-            <a:off x="4168775" y="4064000"/>
+            <a:off x="4168775" y="3149600"/>
             <a:ext cx="177800" cy="101600"/>
           </a:xfrm>
           <a:prstGeom prst="rect">
@@ -12850,7 +12850,7 @@
         </p:nvSpPr>
         <p:spPr>
           <a:xfrm>
-            <a:off x="4473575" y="3902075"/>
+            <a:off x="4473575" y="2987675"/>
             <a:ext cx="1060450" cy="425450"/>
           </a:xfrm>
           <a:prstGeom prst="roundRect">
@@ -12908,7 +12908,7 @@
         </p:blipFill>
         <p:spPr>
           <a:xfrm>
-            <a:off x="5661025" y="4064000"/>
+            <a:off x="5661025" y="3149600"/>
             <a:ext cx="177800" cy="101600"/>
           </a:xfrm>
           <a:prstGeom prst="rect">
@@ -12924,7 +12924,7 @@
         </p:nvSpPr>
         <p:spPr>
           <a:xfrm>
-            <a:off x="5965825" y="3902075"/>
+            <a:off x="5965825" y="2987675"/>
             <a:ext cx="1174750" cy="425450"/>
           </a:xfrm>
           <a:prstGeom prst="roundRect">
@@ -12982,7 +12982,7 @@
         </p:blipFill>
         <p:spPr>
           <a:xfrm>
-            <a:off x="7267575" y="4064000"/>
+            <a:off x="7267575" y="3149600"/>
             <a:ext cx="177800" cy="101600"/>
           </a:xfrm>
           <a:prstGeom prst="rect">
@@ -12998,7 +12998,7 @@
         </p:nvSpPr>
         <p:spPr>
           <a:xfrm>
-            <a:off x="7572375" y="3902075"/>
+            <a:off x="7572375" y="2987675"/>
             <a:ext cx="1174750" cy="425450"/>
           </a:xfrm>
           <a:prstGeom prst="roundRect">
@@ -13056,7 +13056,7 @@
         </p:blipFill>
         <p:spPr>
           <a:xfrm>
-            <a:off x="8874125" y="4064000"/>
+            <a:off x="8874125" y="3149600"/>
             <a:ext cx="177800" cy="101600"/>
           </a:xfrm>
           <a:prstGeom prst="rect">
@@ -13072,7 +13072,7 @@
         </p:nvSpPr>
         <p:spPr>
           <a:xfrm>
-            <a:off x="9178925" y="3902075"/>
+            <a:off x="9178925" y="2987675"/>
             <a:ext cx="946150" cy="425450"/>
           </a:xfrm>
           <a:prstGeom prst="roundRect">
@@ -13130,7 +13130,7 @@
         </p:blipFill>
         <p:spPr>
           <a:xfrm>
-            <a:off x="10252075" y="4064000"/>
+            <a:off x="10252075" y="3149600"/>
             <a:ext cx="177800" cy="101600"/>
           </a:xfrm>
           <a:prstGeom prst="rect">
@@ -13146,7 +13146,7 @@
         </p:nvSpPr>
         <p:spPr>
           <a:xfrm>
-            <a:off x="10553700" y="3905250"/>
+            <a:off x="10553700" y="2990850"/>
             <a:ext cx="825500" cy="419100"/>
           </a:xfrm>
           <a:prstGeom prst="roundRect">
@@ -13185,6 +13185,144 @@
             <a:endParaRPr lang="en-US" sz="1500" dirty="0"/>
           </a:p>
         </p:txBody>
+      </p:sp>
+      <p:sp>
+        <p:nvSpPr>
+          <p:cNvPr id="30" name="Text 20"/>
+          <p:cNvSpPr/>
+          <p:nvPr/>
+        </p:nvSpPr>
+        <p:spPr>
+          <a:xfrm>
+            <a:off x="812800" y="3683000"/>
+            <a:ext cx="5363210" cy="238720"/>
+          </a:xfrm>
+          <a:prstGeom prst="rect">
+            <a:avLst/>
+          </a:prstGeom>
+          <a:noFill/>
+          <a:ln/>
+        </p:spPr>
+        <p:txBody>
+          <a:bodyPr wrap="square" lIns="0" tIns="0" rIns="0" bIns="0" rtlCol="0" anchor="t">
+            <a:normAutofit/>
+          </a:bodyPr>
+          <a:lstStyle/>
+          <a:p>
+            <a:pPr algn="l" indent="0" marL="0">
+              <a:lnSpc>
+                <a:spcPts val="1680"/>
+              </a:lnSpc>
+              <a:buNone/>
+            </a:pPr>
+            <a:r>
+              <a:rPr lang="en-US" sz="1200" spc="150" kern="0" dirty="0">
+                <a:solidFill>
+                  <a:srgbClr val="FFD166"/>
+                </a:solidFill>
+                <a:latin typeface="JetBrains Mono" pitchFamily="49" charset="0"/>
+                <a:ea typeface="JetBrains Mono" pitchFamily="49" charset="-122"/>
+                <a:cs typeface="JetBrains Mono" pitchFamily="49" charset="-120"/>
+              </a:rPr>
+              <a:t>EN VISUAL STUDIO</a:t>
+            </a:r>
+            <a:endParaRPr lang="en-US" sz="1200" dirty="0"/>
+          </a:p>
+        </p:txBody>
+      </p:sp>
+      <p:sp>
+        <p:nvSpPr>
+          <p:cNvPr id="31" name="Text 21"/>
+          <p:cNvSpPr/>
+          <p:nvPr/>
+        </p:nvSpPr>
+        <p:spPr>
+          <a:xfrm>
+            <a:off x="812800" y="3997920"/>
+            <a:ext cx="5363210" cy="558800"/>
+          </a:xfrm>
+          <a:prstGeom prst="rect">
+            <a:avLst/>
+          </a:prstGeom>
+          <a:noFill/>
+          <a:ln/>
+        </p:spPr>
+        <p:txBody>
+          <a:bodyPr wrap="square" lIns="0" tIns="0" rIns="0" bIns="0" rtlCol="0" anchor="t">
+            <a:normAutofit/>
+          </a:bodyPr>
+          <a:lstStyle/>
+          <a:p>
+            <a:pPr algn="l" indent="0" marL="0">
+              <a:lnSpc>
+                <a:spcPts val="2100"/>
+              </a:lnSpc>
+              <a:buNone/>
+            </a:pPr>
+            <a:r>
+              <a:rPr lang="en-US" sz="1500" dirty="0">
+                <a:solidFill>
+                  <a:srgbClr val="F7F9FF"/>
+                </a:solidFill>
+                <a:latin typeface="IBM Plex Sans" pitchFamily="34" charset="0"/>
+                <a:ea typeface="IBM Plex Sans" pitchFamily="34" charset="-122"/>
+                <a:cs typeface="IBM Plex Sans" pitchFamily="34" charset="-120"/>
+              </a:rPr>
+              <a:t>Control Flow de Maestro.dtsx: Limpiar SQL y un Execute Package por tabla, encadenados por éxito.</a:t>
+            </a:r>
+            <a:endParaRPr lang="en-US" sz="1500" dirty="0"/>
+          </a:p>
+        </p:txBody>
+      </p:sp>
+      <p:pic>
+        <p:nvPicPr>
+          <p:cNvPr id="32" name="Image 8" descr="Control Flow del paquete Maestro.dtsx en Visual Studio">    </p:cNvPr>
+          <p:cNvPicPr>
+            <a:picLocks noChangeAspect="1"/>
+          </p:cNvPicPr>
+          <p:nvPr/>
+        </p:nvPicPr>
+        <p:blipFill>
+          <a:blip r:embed="rId9"/>
+          <a:srcRect l="0" r="0" t="0" b="15196"/>
+          <a:stretch/>
+        </p:blipFill>
+        <p:spPr>
+          <a:xfrm>
+            <a:off x="6106815" y="3695700"/>
+            <a:ext cx="5835848" cy="2147193"/>
+          </a:xfrm>
+          <a:prstGeom prst="roundRect">
+            <a:avLst>
+              <a:gd name="adj" fmla="val 2957"/>
+            </a:avLst>
+          </a:prstGeom>
+        </p:spPr>
+      </p:pic>
+      <p:sp>
+        <p:nvSpPr>
+          <p:cNvPr id="33" name="Shape 22"/>
+          <p:cNvSpPr/>
+          <p:nvPr/>
+        </p:nvSpPr>
+        <p:spPr>
+          <a:xfrm>
+            <a:off x="6100465" y="3689350"/>
+            <a:ext cx="5848548" cy="2159893"/>
+          </a:xfrm>
+          <a:prstGeom prst="roundRect">
+            <a:avLst>
+              <a:gd name="adj" fmla="val 3234"/>
+            </a:avLst>
+          </a:prstGeom>
+          <a:noFill/>
+          <a:ln w="12700">
+            <a:solidFill>
+              <a:srgbClr val="6E95F7"/>
+            </a:solidFill>
+            <a:prstDash val="solid"/>
+          </a:ln>
+        </p:spPr>
       </p:sp>
     </p:spTree>
   </p:cSld>
@@ -15252,66 +15390,29 @@
       </p:sp>
       <p:sp>
         <p:nvSpPr>
-          <p:cNvPr id="4" name="Text 2"/>
+          <p:cNvPr id="4" name="Shape 2"/>
           <p:cNvSpPr/>
           <p:nvPr/>
         </p:nvSpPr>
         <p:spPr>
           <a:xfrm>
             <a:off x="812800" y="1803301"/>
-            <a:ext cx="4826000" cy="391120"/>
+            <a:ext cx="5207000" cy="3302000"/>
           </a:xfrm>
           <a:prstGeom prst="roundRect">
             <a:avLst>
-              <a:gd name="adj" fmla="val 16235"/>
+              <a:gd name="adj" fmla="val 2308"/>
             </a:avLst>
           </a:prstGeom>
           <a:solidFill>
-            <a:srgbClr val="2459E0"/>
+            <a:srgbClr val="262626"/>
           </a:solidFill>
           <a:ln/>
         </p:spPr>
-        <p:txBody>
-          <a:bodyPr wrap="square" lIns="133801" tIns="70301" rIns="0" bIns="44901" rtlCol="0" anchor="t">
-            <a:normAutofit/>
-          </a:bodyPr>
-          <a:lstStyle/>
-          <a:p>
-            <a:pPr algn="l" indent="0" marL="0">
-              <a:lnSpc>
-                <a:spcPts val="1680"/>
-              </a:lnSpc>
-              <a:buNone/>
-            </a:pPr>
-            <a:r>
-              <a:rPr lang="en-US" sz="1200" b="1" dirty="0">
-                <a:solidFill>
-                  <a:srgbClr val="F7F9FF"/>
-                </a:solidFill>
-                <a:latin typeface="JetBrains Mono" pitchFamily="49" charset="0"/>
-                <a:ea typeface="JetBrains Mono" pitchFamily="49" charset="-122"/>
-                <a:cs typeface="JetBrains Mono" pitchFamily="49" charset="-120"/>
-              </a:rPr>
-              <a:t>OLE DB Source</a:t>
-            </a:r>
-            <a:r>
-              <a:rPr lang="en-US" sz="1200" dirty="0">
-                <a:solidFill>
-                  <a:srgbClr val="F7F9FF"/>
-                </a:solidFill>
-                <a:latin typeface="JetBrains Mono" pitchFamily="49" charset="0"/>
-                <a:ea typeface="JetBrains Mono" pitchFamily="49" charset="-122"/>
-                <a:cs typeface="JetBrains Mono" pitchFamily="49" charset="-120"/>
-              </a:rPr>
-              <a:t> · DetalleOrden ⋈ Ordenes</a:t>
-            </a:r>
-            <a:endParaRPr lang="en-US" sz="1200" dirty="0"/>
-          </a:p>
-        </p:txBody>
       </p:sp>
       <p:pic>
         <p:nvPicPr>
-          <p:cNvPr id="5" name="Image 0" descr="arrow-down">    </p:cNvPr>
+          <p:cNvPr id="5" name="Image 0" descr="Data Flow de Fact_Detalle_Venta en Visual Studio: Origen OLE DB, Lookups de Cliente, Producto, Empleado y Transportista, y Destino OLE DB">    </p:cNvPr>
           <p:cNvPicPr>
             <a:picLocks noChangeAspect="1"/>
           </p:cNvPicPr>
@@ -15319,33 +15420,104 @@
         </p:nvPicPr>
         <p:blipFill>
           <a:blip r:embed="rId1"/>
-          <a:srcRect l="0" r="0" t="0" b="0"/>
+          <a:srcRect l="-156" r="-156" t="0" b="0"/>
           <a:stretch/>
         </p:blipFill>
         <p:spPr>
           <a:xfrm>
-            <a:off x="3149600" y="2232521"/>
-            <a:ext cx="152400" cy="203200"/>
-          </a:xfrm>
-          <a:prstGeom prst="rect">
-            <a:avLst/>
-          </a:prstGeom>
-        </p:spPr>
-      </p:pic>
-      <p:sp>
-        <p:nvSpPr>
-          <p:cNvPr id="6" name="Text 3"/>
-          <p:cNvSpPr/>
-          <p:nvPr/>
-        </p:nvSpPr>
-        <p:spPr>
-          <a:xfrm>
-            <a:off x="815975" y="2476996"/>
-            <a:ext cx="4819650" cy="397470"/>
+            <a:off x="825500" y="1816001"/>
+            <a:ext cx="5181600" cy="3276600"/>
           </a:xfrm>
           <a:prstGeom prst="roundRect">
             <a:avLst>
-              <a:gd name="adj" fmla="val 15177"/>
+              <a:gd name="adj" fmla="val 1938"/>
+            </a:avLst>
+          </a:prstGeom>
+        </p:spPr>
+      </p:pic>
+      <p:sp>
+        <p:nvSpPr>
+          <p:cNvPr id="6" name="Shape 3"/>
+          <p:cNvSpPr/>
+          <p:nvPr/>
+        </p:nvSpPr>
+        <p:spPr>
+          <a:xfrm>
+            <a:off x="819150" y="1809651"/>
+            <a:ext cx="5194300" cy="3289300"/>
+          </a:xfrm>
+          <a:prstGeom prst="roundRect">
+            <a:avLst>
+              <a:gd name="adj" fmla="val 2124"/>
+            </a:avLst>
+          </a:prstGeom>
+          <a:noFill/>
+          <a:ln w="12700">
+            <a:solidFill>
+              <a:srgbClr val="BFD0F5"/>
+            </a:solidFill>
+            <a:prstDash val="solid"/>
+          </a:ln>
+        </p:spPr>
+      </p:sp>
+      <p:sp>
+        <p:nvSpPr>
+          <p:cNvPr id="7" name="Text 4"/>
+          <p:cNvSpPr/>
+          <p:nvPr/>
+        </p:nvSpPr>
+        <p:spPr>
+          <a:xfrm>
+            <a:off x="812800" y="5181501"/>
+            <a:ext cx="6248400" cy="238720"/>
+          </a:xfrm>
+          <a:prstGeom prst="rect">
+            <a:avLst/>
+          </a:prstGeom>
+          <a:noFill/>
+          <a:ln/>
+        </p:spPr>
+        <p:txBody>
+          <a:bodyPr wrap="square" lIns="0" tIns="0" rIns="0" bIns="0" rtlCol="0" anchor="t">
+            <a:normAutofit/>
+          </a:bodyPr>
+          <a:lstStyle/>
+          <a:p>
+            <a:pPr algn="l" indent="0" marL="0">
+              <a:lnSpc>
+                <a:spcPts val="1680"/>
+              </a:lnSpc>
+              <a:buNone/>
+            </a:pPr>
+            <a:r>
+              <a:rPr lang="en-US" sz="1200" dirty="0">
+                <a:solidFill>
+                  <a:srgbClr val="5F6B85"/>
+                </a:solidFill>
+                <a:latin typeface="IBM Plex Sans" pitchFamily="34" charset="0"/>
+                <a:ea typeface="IBM Plex Sans" pitchFamily="34" charset="-122"/>
+                <a:cs typeface="IBM Plex Sans" pitchFamily="34" charset="-120"/>
+              </a:rPr>
+              <a:t>Data Flow en Visual Studio: Origen OLE DB → 4 Lookups → Destino OLE DB</a:t>
+            </a:r>
+            <a:endParaRPr lang="en-US" sz="1200" dirty="0"/>
+          </a:p>
+        </p:txBody>
+      </p:sp>
+      <p:sp>
+        <p:nvSpPr>
+          <p:cNvPr id="8" name="Shape 5"/>
+          <p:cNvSpPr/>
+          <p:nvPr/>
+        </p:nvSpPr>
+        <p:spPr>
+          <a:xfrm>
+            <a:off x="6429375" y="1806476"/>
+            <a:ext cx="4946650" cy="1949152"/>
+          </a:xfrm>
+          <a:prstGeom prst="roundRect">
+            <a:avLst>
+              <a:gd name="adj" fmla="val 3747"/>
             </a:avLst>
           </a:prstGeom>
           <a:solidFill>
@@ -15358,497 +15530,310 @@
             <a:prstDash val="solid"/>
           </a:ln>
         </p:spPr>
-        <p:txBody>
-          <a:bodyPr wrap="square" lIns="137906" tIns="74406" rIns="2651" bIns="49006" rtlCol="0" anchor="t">
+      </p:sp>
+      <p:sp>
+        <p:nvSpPr>
+          <p:cNvPr id="9" name="Text 6"/>
+          <p:cNvSpPr/>
+          <p:nvPr/>
+        </p:nvSpPr>
+        <p:spPr>
+          <a:xfrm>
+            <a:off x="6635750" y="2012851"/>
+            <a:ext cx="4669917" cy="254000"/>
+          </a:xfrm>
+          <a:prstGeom prst="rect">
+            <a:avLst/>
+          </a:prstGeom>
+          <a:noFill/>
+          <a:ln/>
+        </p:spPr>
+        <p:txBody>
+          <a:bodyPr wrap="square" lIns="0" tIns="0" rIns="0" bIns="0" rtlCol="0" anchor="t">
             <a:normAutofit/>
           </a:bodyPr>
           <a:lstStyle/>
           <a:p>
             <a:pPr algn="l" indent="0" marL="0">
               <a:lnSpc>
-                <a:spcPts val="1680"/>
-              </a:lnSpc>
-              <a:buNone/>
-            </a:pPr>
-            <a:r>
-              <a:rPr lang="en-US" sz="1200" b="1" dirty="0">
+                <a:spcPts val="1800"/>
+              </a:lnSpc>
+              <a:buNone/>
+            </a:pPr>
+            <a:r>
+              <a:rPr lang="en-US" sz="1500" b="1" dirty="0">
                 <a:solidFill>
                   <a:srgbClr val="1B2A4A"/>
+                </a:solidFill>
+                <a:latin typeface="IBM Plex Sans" pitchFamily="34" charset="0"/>
+                <a:ea typeface="IBM Plex Sans" pitchFamily="34" charset="-122"/>
+                <a:cs typeface="IBM Plex Sans" pitchFamily="34" charset="-120"/>
+              </a:rPr>
+              <a:t>Calculado en la consulta de origen</a:t>
+            </a:r>
+            <a:endParaRPr lang="en-US" sz="1500" dirty="0"/>
+          </a:p>
+        </p:txBody>
+      </p:sp>
+      <p:sp>
+        <p:nvSpPr>
+          <p:cNvPr id="10" name="Text 7"/>
+          <p:cNvSpPr/>
+          <p:nvPr/>
+        </p:nvSpPr>
+        <p:spPr>
+          <a:xfrm>
+            <a:off x="6635750" y="2330351"/>
+            <a:ext cx="4669917" cy="269180"/>
+          </a:xfrm>
+          <a:prstGeom prst="rect">
+            <a:avLst/>
+          </a:prstGeom>
+          <a:noFill/>
+          <a:ln/>
+        </p:spPr>
+        <p:txBody>
+          <a:bodyPr wrap="square" lIns="0" tIns="0" rIns="0" bIns="0" rtlCol="0" anchor="t">
+            <a:normAutofit/>
+          </a:bodyPr>
+          <a:lstStyle/>
+          <a:p>
+            <a:pPr algn="l" indent="0" marL="0">
+              <a:lnSpc>
+                <a:spcPts val="1920"/>
+              </a:lnSpc>
+              <a:buNone/>
+            </a:pPr>
+            <a:r>
+              <a:rPr lang="en-US" sz="1200" dirty="0">
+                <a:solidFill>
+                  <a:srgbClr val="3B4660"/>
                 </a:solidFill>
                 <a:latin typeface="JetBrains Mono" pitchFamily="49" charset="0"/>
                 <a:ea typeface="JetBrains Mono" pitchFamily="49" charset="-122"/>
                 <a:cs typeface="JetBrains Mono" pitchFamily="49" charset="-120"/>
               </a:rPr>
-              <a:t>Lookup</a:t>
-            </a:r>
+              <a:t>MontoBruto = Cantidad × Precio</a:t>
+            </a:r>
+            <a:endParaRPr lang="en-US" sz="1200" dirty="0"/>
+          </a:p>
+        </p:txBody>
+      </p:sp>
+      <p:sp>
+        <p:nvSpPr>
+          <p:cNvPr id="11" name="Text 8"/>
+          <p:cNvSpPr/>
+          <p:nvPr/>
+        </p:nvSpPr>
+        <p:spPr>
+          <a:xfrm>
+            <a:off x="6635750" y="2574131"/>
+            <a:ext cx="4669917" cy="269180"/>
+          </a:xfrm>
+          <a:prstGeom prst="rect">
+            <a:avLst/>
+          </a:prstGeom>
+          <a:noFill/>
+          <a:ln/>
+        </p:spPr>
+        <p:txBody>
+          <a:bodyPr wrap="square" lIns="0" tIns="0" rIns="0" bIns="0" rtlCol="0" anchor="t">
+            <a:normAutofit/>
+          </a:bodyPr>
+          <a:lstStyle/>
+          <a:p>
+            <a:pPr algn="l" indent="0" marL="0">
+              <a:lnSpc>
+                <a:spcPts val="1920"/>
+              </a:lnSpc>
+              <a:buNone/>
+            </a:pPr>
             <a:r>
               <a:rPr lang="en-US" sz="1200" dirty="0">
                 <a:solidFill>
-                  <a:srgbClr val="1B2A4A"/>
+                  <a:srgbClr val="3B4660"/>
                 </a:solidFill>
                 <a:latin typeface="JetBrains Mono" pitchFamily="49" charset="0"/>
                 <a:ea typeface="JetBrains Mono" pitchFamily="49" charset="-122"/>
                 <a:cs typeface="JetBrains Mono" pitchFamily="49" charset="-120"/>
               </a:rPr>
-              <a:t> ClienteID → ClienteKey</a:t>
+              <a:t>MontoDescuento = Bruto × Descuento</a:t>
             </a:r>
             <a:endParaRPr lang="en-US" sz="1200" dirty="0"/>
           </a:p>
         </p:txBody>
       </p:sp>
-      <p:pic>
-        <p:nvPicPr>
-          <p:cNvPr id="7" name="Image 1" descr="arrow-down">    </p:cNvPr>
-          <p:cNvPicPr>
-            <a:picLocks noChangeAspect="1"/>
-          </p:cNvPicPr>
-          <p:nvPr/>
-        </p:nvPicPr>
-        <p:blipFill>
-          <a:blip r:embed="rId2"/>
-          <a:srcRect l="0" r="0" t="0" b="0"/>
-          <a:stretch/>
-        </p:blipFill>
-        <p:spPr>
-          <a:xfrm>
-            <a:off x="3149600" y="2915741"/>
-            <a:ext cx="152400" cy="203200"/>
-          </a:xfrm>
-          <a:prstGeom prst="rect">
-            <a:avLst/>
-          </a:prstGeom>
-        </p:spPr>
-      </p:pic>
-      <p:sp>
-        <p:nvSpPr>
-          <p:cNvPr id="8" name="Text 4"/>
-          <p:cNvSpPr/>
-          <p:nvPr/>
-        </p:nvSpPr>
-        <p:spPr>
-          <a:xfrm>
-            <a:off x="815975" y="3160216"/>
-            <a:ext cx="4819650" cy="397470"/>
-          </a:xfrm>
-          <a:prstGeom prst="roundRect">
-            <a:avLst>
-              <a:gd name="adj" fmla="val 15177"/>
-            </a:avLst>
-          </a:prstGeom>
-          <a:solidFill>
-            <a:srgbClr val="FEFEFF"/>
-          </a:solidFill>
-          <a:ln w="6350">
-            <a:solidFill>
-              <a:srgbClr val="DCE3F0"/>
-            </a:solidFill>
-            <a:prstDash val="solid"/>
-          </a:ln>
-        </p:spPr>
-        <p:txBody>
-          <a:bodyPr wrap="square" lIns="137906" tIns="74406" rIns="2651" bIns="49006" rtlCol="0" anchor="t">
+      <p:sp>
+        <p:nvSpPr>
+          <p:cNvPr id="12" name="Text 9"/>
+          <p:cNvSpPr/>
+          <p:nvPr/>
+        </p:nvSpPr>
+        <p:spPr>
+          <a:xfrm>
+            <a:off x="6635750" y="2817912"/>
+            <a:ext cx="4669917" cy="269180"/>
+          </a:xfrm>
+          <a:prstGeom prst="rect">
+            <a:avLst/>
+          </a:prstGeom>
+          <a:noFill/>
+          <a:ln/>
+        </p:spPr>
+        <p:txBody>
+          <a:bodyPr wrap="square" lIns="0" tIns="0" rIns="0" bIns="0" rtlCol="0" anchor="t">
             <a:normAutofit/>
           </a:bodyPr>
           <a:lstStyle/>
           <a:p>
             <a:pPr algn="l" indent="0" marL="0">
               <a:lnSpc>
-                <a:spcPts val="1680"/>
-              </a:lnSpc>
-              <a:buNone/>
-            </a:pPr>
-            <a:r>
-              <a:rPr lang="en-US" sz="1200" b="1" dirty="0">
-                <a:solidFill>
-                  <a:srgbClr val="1B2A4A"/>
+                <a:spcPts val="1920"/>
+              </a:lnSpc>
+              <a:buNone/>
+            </a:pPr>
+            <a:r>
+              <a:rPr lang="en-US" sz="1200" dirty="0">
+                <a:solidFill>
+                  <a:srgbClr val="3B4660"/>
                 </a:solidFill>
                 <a:latin typeface="JetBrains Mono" pitchFamily="49" charset="0"/>
                 <a:ea typeface="JetBrains Mono" pitchFamily="49" charset="-122"/>
                 <a:cs typeface="JetBrains Mono" pitchFamily="49" charset="-120"/>
               </a:rPr>
-              <a:t>Lookup</a:t>
-            </a:r>
+              <a:t>MontoNeto = Bruto − Descuento</a:t>
+            </a:r>
+            <a:endParaRPr lang="en-US" sz="1200" dirty="0"/>
+          </a:p>
+        </p:txBody>
+      </p:sp>
+      <p:sp>
+        <p:nvSpPr>
+          <p:cNvPr id="13" name="Text 10"/>
+          <p:cNvSpPr/>
+          <p:nvPr/>
+        </p:nvSpPr>
+        <p:spPr>
+          <a:xfrm>
+            <a:off x="6635750" y="3061692"/>
+            <a:ext cx="4669917" cy="269180"/>
+          </a:xfrm>
+          <a:prstGeom prst="rect">
+            <a:avLst/>
+          </a:prstGeom>
+          <a:noFill/>
+          <a:ln/>
+        </p:spPr>
+        <p:txBody>
+          <a:bodyPr wrap="square" lIns="0" tIns="0" rIns="0" bIns="0" rtlCol="0" anchor="t">
+            <a:normAutofit/>
+          </a:bodyPr>
+          <a:lstStyle/>
+          <a:p>
+            <a:pPr algn="l" indent="0" marL="0">
+              <a:lnSpc>
+                <a:spcPts val="1920"/>
+              </a:lnSpc>
+              <a:buNone/>
+            </a:pPr>
             <a:r>
               <a:rPr lang="en-US" sz="1200" dirty="0">
                 <a:solidFill>
-                  <a:srgbClr val="1B2A4A"/>
+                  <a:srgbClr val="3B4660"/>
                 </a:solidFill>
                 <a:latin typeface="JetBrains Mono" pitchFamily="49" charset="0"/>
                 <a:ea typeface="JetBrains Mono" pitchFamily="49" charset="-122"/>
                 <a:cs typeface="JetBrains Mono" pitchFamily="49" charset="-120"/>
               </a:rPr>
-              <a:t> EmpleadoID → EmpleadoKey</a:t>
+              <a:t>DiasDespacho = Envío − Orden</a:t>
             </a:r>
             <a:endParaRPr lang="en-US" sz="1200" dirty="0"/>
           </a:p>
         </p:txBody>
       </p:sp>
-      <p:pic>
-        <p:nvPicPr>
-          <p:cNvPr id="9" name="Image 2" descr="arrow-down">    </p:cNvPr>
-          <p:cNvPicPr>
-            <a:picLocks noChangeAspect="1"/>
-          </p:cNvPicPr>
-          <p:nvPr/>
-        </p:nvPicPr>
-        <p:blipFill>
-          <a:blip r:embed="rId3"/>
-          <a:srcRect l="0" r="0" t="0" b="0"/>
-          <a:stretch/>
-        </p:blipFill>
-        <p:spPr>
-          <a:xfrm>
-            <a:off x="3149600" y="3598962"/>
-            <a:ext cx="152400" cy="203200"/>
-          </a:xfrm>
-          <a:prstGeom prst="rect">
-            <a:avLst/>
-          </a:prstGeom>
-        </p:spPr>
-      </p:pic>
-      <p:sp>
-        <p:nvSpPr>
-          <p:cNvPr id="10" name="Text 5"/>
-          <p:cNvSpPr/>
-          <p:nvPr/>
-        </p:nvSpPr>
-        <p:spPr>
-          <a:xfrm>
-            <a:off x="815975" y="3843437"/>
-            <a:ext cx="4819650" cy="397470"/>
-          </a:xfrm>
-          <a:prstGeom prst="roundRect">
-            <a:avLst>
-              <a:gd name="adj" fmla="val 15177"/>
-            </a:avLst>
-          </a:prstGeom>
-          <a:solidFill>
-            <a:srgbClr val="FEFEFF"/>
-          </a:solidFill>
-          <a:ln w="6350">
-            <a:solidFill>
-              <a:srgbClr val="DCE3F0"/>
-            </a:solidFill>
-            <a:prstDash val="solid"/>
-          </a:ln>
-        </p:spPr>
-        <p:txBody>
-          <a:bodyPr wrap="square" lIns="137906" tIns="74406" rIns="2651" bIns="49006" rtlCol="0" anchor="t">
+      <p:sp>
+        <p:nvSpPr>
+          <p:cNvPr id="14" name="Text 11"/>
+          <p:cNvSpPr/>
+          <p:nvPr/>
+        </p:nvSpPr>
+        <p:spPr>
+          <a:xfrm>
+            <a:off x="6635750" y="3305473"/>
+            <a:ext cx="4669917" cy="269180"/>
+          </a:xfrm>
+          <a:prstGeom prst="rect">
+            <a:avLst/>
+          </a:prstGeom>
+          <a:noFill/>
+          <a:ln/>
+        </p:spPr>
+        <p:txBody>
+          <a:bodyPr wrap="square" lIns="0" tIns="0" rIns="0" bIns="0" rtlCol="0" anchor="t">
             <a:normAutofit/>
           </a:bodyPr>
           <a:lstStyle/>
           <a:p>
             <a:pPr algn="l" indent="0" marL="0">
               <a:lnSpc>
-                <a:spcPts val="1680"/>
-              </a:lnSpc>
-              <a:buNone/>
-            </a:pPr>
-            <a:r>
-              <a:rPr lang="en-US" sz="1200" b="1" dirty="0">
-                <a:solidFill>
-                  <a:srgbClr val="1B2A4A"/>
+                <a:spcPts val="1920"/>
+              </a:lnSpc>
+              <a:buNone/>
+            </a:pPr>
+            <a:r>
+              <a:rPr lang="en-US" sz="1200" dirty="0">
+                <a:solidFill>
+                  <a:srgbClr val="3B4660"/>
                 </a:solidFill>
                 <a:latin typeface="JetBrains Mono" pitchFamily="49" charset="0"/>
                 <a:ea typeface="JetBrains Mono" pitchFamily="49" charset="-122"/>
                 <a:cs typeface="JetBrains Mono" pitchFamily="49" charset="-120"/>
               </a:rPr>
-              <a:t>Lookup</a:t>
-            </a:r>
+              <a:t>FechaKey = CONVERT(…, 112)</a:t>
+            </a:r>
+            <a:endParaRPr lang="en-US" sz="1200" dirty="0"/>
+          </a:p>
+        </p:txBody>
+      </p:sp>
+      <p:sp>
+        <p:nvSpPr>
+          <p:cNvPr id="15" name="Text 12"/>
+          <p:cNvSpPr/>
+          <p:nvPr/>
+        </p:nvSpPr>
+        <p:spPr>
+          <a:xfrm>
+            <a:off x="812800" y="6236990"/>
+            <a:ext cx="1930360" cy="238720"/>
+          </a:xfrm>
+          <a:prstGeom prst="rect">
+            <a:avLst/>
+          </a:prstGeom>
+          <a:noFill/>
+          <a:ln/>
+        </p:spPr>
+        <p:txBody>
+          <a:bodyPr wrap="square" lIns="0" tIns="0" rIns="0" bIns="0" rtlCol="0" anchor="t">
+            <a:normAutofit/>
+          </a:bodyPr>
+          <a:lstStyle/>
+          <a:p>
+            <a:pPr algn="l" indent="0" marL="0">
+              <a:lnSpc>
+                <a:spcPts val="1680"/>
+              </a:lnSpc>
+              <a:buNone/>
+            </a:pPr>
             <a:r>
               <a:rPr lang="en-US" sz="1200" dirty="0">
                 <a:solidFill>
-                  <a:srgbClr val="1B2A4A"/>
-                </a:solidFill>
-                <a:latin typeface="JetBrains Mono" pitchFamily="49" charset="0"/>
-                <a:ea typeface="JetBrains Mono" pitchFamily="49" charset="-122"/>
-                <a:cs typeface="JetBrains Mono" pitchFamily="49" charset="-120"/>
-              </a:rPr>
-              <a:t> ProductoID → ProductoKey</a:t>
-            </a:r>
-            <a:endParaRPr lang="en-US" sz="1200" dirty="0"/>
-          </a:p>
-        </p:txBody>
-      </p:sp>
-      <p:pic>
-        <p:nvPicPr>
-          <p:cNvPr id="11" name="Image 3" descr="arrow-down">    </p:cNvPr>
-          <p:cNvPicPr>
-            <a:picLocks noChangeAspect="1"/>
-          </p:cNvPicPr>
-          <p:nvPr/>
-        </p:nvPicPr>
-        <p:blipFill>
-          <a:blip r:embed="rId4"/>
-          <a:srcRect l="0" r="0" t="0" b="0"/>
-          <a:stretch/>
-        </p:blipFill>
-        <p:spPr>
-          <a:xfrm>
-            <a:off x="3149600" y="4282182"/>
-            <a:ext cx="152400" cy="203200"/>
-          </a:xfrm>
-          <a:prstGeom prst="rect">
-            <a:avLst/>
-          </a:prstGeom>
-        </p:spPr>
-      </p:pic>
-      <p:sp>
-        <p:nvSpPr>
-          <p:cNvPr id="12" name="Text 6"/>
-          <p:cNvSpPr/>
-          <p:nvPr/>
-        </p:nvSpPr>
-        <p:spPr>
-          <a:xfrm>
-            <a:off x="815975" y="4526657"/>
-            <a:ext cx="4819650" cy="397470"/>
-          </a:xfrm>
-          <a:prstGeom prst="roundRect">
-            <a:avLst>
-              <a:gd name="adj" fmla="val 15177"/>
-            </a:avLst>
-          </a:prstGeom>
-          <a:solidFill>
-            <a:srgbClr val="FEFEFF"/>
-          </a:solidFill>
-          <a:ln w="6350">
-            <a:solidFill>
-              <a:srgbClr val="DCE3F0"/>
-            </a:solidFill>
-            <a:prstDash val="solid"/>
-          </a:ln>
-        </p:spPr>
-        <p:txBody>
-          <a:bodyPr wrap="square" lIns="137906" tIns="74406" rIns="2651" bIns="49006" rtlCol="0" anchor="t">
-            <a:normAutofit/>
-          </a:bodyPr>
-          <a:lstStyle/>
-          <a:p>
-            <a:pPr algn="l" indent="0" marL="0">
-              <a:lnSpc>
-                <a:spcPts val="1680"/>
-              </a:lnSpc>
-              <a:buNone/>
-            </a:pPr>
-            <a:r>
-              <a:rPr lang="en-US" sz="1200" b="1" dirty="0">
-                <a:solidFill>
-                  <a:srgbClr val="1B2A4A"/>
-                </a:solidFill>
-                <a:latin typeface="JetBrains Mono" pitchFamily="49" charset="0"/>
-                <a:ea typeface="JetBrains Mono" pitchFamily="49" charset="-122"/>
-                <a:cs typeface="JetBrains Mono" pitchFamily="49" charset="-120"/>
-              </a:rPr>
-              <a:t>Lookup</a:t>
-            </a:r>
-            <a:r>
-              <a:rPr lang="en-US" sz="1200" dirty="0">
-                <a:solidFill>
-                  <a:srgbClr val="1B2A4A"/>
-                </a:solidFill>
-                <a:latin typeface="JetBrains Mono" pitchFamily="49" charset="0"/>
-                <a:ea typeface="JetBrains Mono" pitchFamily="49" charset="-122"/>
-                <a:cs typeface="JetBrains Mono" pitchFamily="49" charset="-120"/>
-              </a:rPr>
-              <a:t> TransportistaID → TransportistaKey</a:t>
-            </a:r>
-            <a:endParaRPr lang="en-US" sz="1200" dirty="0"/>
-          </a:p>
-        </p:txBody>
-      </p:sp>
-      <p:pic>
-        <p:nvPicPr>
-          <p:cNvPr id="13" name="Image 4" descr="arrow-down">    </p:cNvPr>
-          <p:cNvPicPr>
-            <a:picLocks noChangeAspect="1"/>
-          </p:cNvPicPr>
-          <p:nvPr/>
-        </p:nvPicPr>
-        <p:blipFill>
-          <a:blip r:embed="rId5"/>
-          <a:srcRect l="0" r="0" t="0" b="0"/>
-          <a:stretch/>
-        </p:blipFill>
-        <p:spPr>
-          <a:xfrm>
-            <a:off x="3149600" y="4965402"/>
-            <a:ext cx="152400" cy="203200"/>
-          </a:xfrm>
-          <a:prstGeom prst="rect">
-            <a:avLst/>
-          </a:prstGeom>
-        </p:spPr>
-      </p:pic>
-      <p:sp>
-        <p:nvSpPr>
-          <p:cNvPr id="14" name="Text 7"/>
-          <p:cNvSpPr/>
-          <p:nvPr/>
-        </p:nvSpPr>
-        <p:spPr>
-          <a:xfrm>
-            <a:off x="812800" y="5206702"/>
-            <a:ext cx="4826000" cy="391120"/>
-          </a:xfrm>
-          <a:prstGeom prst="roundRect">
-            <a:avLst>
-              <a:gd name="adj" fmla="val 16235"/>
-            </a:avLst>
-          </a:prstGeom>
-          <a:solidFill>
-            <a:srgbClr val="2459E0"/>
-          </a:solidFill>
-          <a:ln/>
-        </p:spPr>
-        <p:txBody>
-          <a:bodyPr wrap="square" lIns="133801" tIns="70301" rIns="0" bIns="44901" rtlCol="0" anchor="t">
-            <a:normAutofit/>
-          </a:bodyPr>
-          <a:lstStyle/>
-          <a:p>
-            <a:pPr algn="l" indent="0" marL="0">
-              <a:lnSpc>
-                <a:spcPts val="1680"/>
-              </a:lnSpc>
-              <a:buNone/>
-            </a:pPr>
-            <a:r>
-              <a:rPr lang="en-US" sz="1200" b="1" dirty="0">
-                <a:solidFill>
-                  <a:srgbClr val="F7F9FF"/>
-                </a:solidFill>
-                <a:latin typeface="JetBrains Mono" pitchFamily="49" charset="0"/>
-                <a:ea typeface="JetBrains Mono" pitchFamily="49" charset="-122"/>
-                <a:cs typeface="JetBrains Mono" pitchFamily="49" charset="-120"/>
-              </a:rPr>
-              <a:t>OLE DB Destination</a:t>
-            </a:r>
-            <a:r>
-              <a:rPr lang="en-US" sz="1200" dirty="0">
-                <a:solidFill>
-                  <a:srgbClr val="F7F9FF"/>
-                </a:solidFill>
-                <a:latin typeface="JetBrains Mono" pitchFamily="49" charset="0"/>
-                <a:ea typeface="JetBrains Mono" pitchFamily="49" charset="-122"/>
-                <a:cs typeface="JetBrains Mono" pitchFamily="49" charset="-120"/>
-              </a:rPr>
-              <a:t> · Fact_Detalle_Venta</a:t>
-            </a:r>
-            <a:endParaRPr lang="en-US" sz="1200" dirty="0"/>
-          </a:p>
-        </p:txBody>
-      </p:sp>
-      <p:sp>
-        <p:nvSpPr>
-          <p:cNvPr id="15" name="Shape 8"/>
-          <p:cNvSpPr/>
-          <p:nvPr/>
-        </p:nvSpPr>
-        <p:spPr>
-          <a:xfrm>
-            <a:off x="6048375" y="1806476"/>
-            <a:ext cx="5327650" cy="1949152"/>
-          </a:xfrm>
-          <a:prstGeom prst="roundRect">
-            <a:avLst>
-              <a:gd name="adj" fmla="val 3747"/>
-            </a:avLst>
-          </a:prstGeom>
-          <a:solidFill>
-            <a:srgbClr val="FEFEFF"/>
-          </a:solidFill>
-          <a:ln w="6350">
-            <a:solidFill>
-              <a:srgbClr val="DCE3F0"/>
-            </a:solidFill>
-            <a:prstDash val="solid"/>
-          </a:ln>
-        </p:spPr>
-      </p:sp>
-      <p:sp>
-        <p:nvSpPr>
-          <p:cNvPr id="16" name="Text 9"/>
-          <p:cNvSpPr/>
-          <p:nvPr/>
-        </p:nvSpPr>
-        <p:spPr>
-          <a:xfrm>
-            <a:off x="6254750" y="2012851"/>
-            <a:ext cx="5062347" cy="254000"/>
-          </a:xfrm>
-          <a:prstGeom prst="rect">
-            <a:avLst/>
-          </a:prstGeom>
-          <a:noFill/>
-          <a:ln/>
-        </p:spPr>
-        <p:txBody>
-          <a:bodyPr wrap="square" lIns="0" tIns="0" rIns="0" bIns="0" rtlCol="0" anchor="t">
-            <a:normAutofit/>
-          </a:bodyPr>
-          <a:lstStyle/>
-          <a:p>
-            <a:pPr algn="l" indent="0" marL="0">
-              <a:lnSpc>
-                <a:spcPts val="1800"/>
-              </a:lnSpc>
-              <a:buNone/>
-            </a:pPr>
-            <a:r>
-              <a:rPr lang="en-US" sz="1500" b="1" dirty="0">
-                <a:solidFill>
-                  <a:srgbClr val="1B2A4A"/>
+                  <a:srgbClr val="5F6B85"/>
                 </a:solidFill>
                 <a:latin typeface="IBM Plex Sans" pitchFamily="34" charset="0"/>
                 <a:ea typeface="IBM Plex Sans" pitchFamily="34" charset="-122"/>
                 <a:cs typeface="IBM Plex Sans" pitchFamily="34" charset="-120"/>
               </a:rPr>
-              <a:t>Calculado en la consulta de origen</a:t>
-            </a:r>
-            <a:endParaRPr lang="en-US" sz="1500" dirty="0"/>
-          </a:p>
-        </p:txBody>
-      </p:sp>
-      <p:sp>
-        <p:nvSpPr>
-          <p:cNvPr id="17" name="Text 10"/>
-          <p:cNvSpPr/>
-          <p:nvPr/>
-        </p:nvSpPr>
-        <p:spPr>
-          <a:xfrm>
-            <a:off x="6254750" y="2330351"/>
-            <a:ext cx="5062347" cy="269180"/>
-          </a:xfrm>
-          <a:prstGeom prst="rect">
-            <a:avLst/>
-          </a:prstGeom>
-          <a:noFill/>
-          <a:ln/>
-        </p:spPr>
-        <p:txBody>
-          <a:bodyPr wrap="square" lIns="0" tIns="0" rIns="0" bIns="0" rtlCol="0" anchor="t">
-            <a:normAutofit/>
-          </a:bodyPr>
-          <a:lstStyle/>
-          <a:p>
-            <a:pPr algn="l" indent="0" marL="0">
-              <a:lnSpc>
-                <a:spcPts val="1920"/>
-              </a:lnSpc>
-              <a:buNone/>
-            </a:pPr>
-            <a:r>
-              <a:rPr lang="en-US" sz="1200" dirty="0">
-                <a:solidFill>
-                  <a:srgbClr val="3B4660"/>
-                </a:solidFill>
-                <a:latin typeface="JetBrains Mono" pitchFamily="49" charset="0"/>
-                <a:ea typeface="JetBrains Mono" pitchFamily="49" charset="-122"/>
-                <a:cs typeface="JetBrains Mono" pitchFamily="49" charset="-120"/>
-              </a:rPr>
-              <a:t>MontoBruto = Cantidad × Precio</a:t>
+              <a:t>Kent Foods DW · Fase 1</a:t>
             </a:r>
             <a:endParaRPr lang="en-US" sz="1200" dirty="0"/>
           </a:p>
@@ -15856,227 +15841,7 @@
       </p:sp>
       <p:sp>
         <p:nvSpPr>
-          <p:cNvPr id="18" name="Text 11"/>
-          <p:cNvSpPr/>
-          <p:nvPr/>
-        </p:nvSpPr>
-        <p:spPr>
-          <a:xfrm>
-            <a:off x="6254750" y="2574131"/>
-            <a:ext cx="5062347" cy="269180"/>
-          </a:xfrm>
-          <a:prstGeom prst="rect">
-            <a:avLst/>
-          </a:prstGeom>
-          <a:noFill/>
-          <a:ln/>
-        </p:spPr>
-        <p:txBody>
-          <a:bodyPr wrap="square" lIns="0" tIns="0" rIns="0" bIns="0" rtlCol="0" anchor="t">
-            <a:normAutofit/>
-          </a:bodyPr>
-          <a:lstStyle/>
-          <a:p>
-            <a:pPr algn="l" indent="0" marL="0">
-              <a:lnSpc>
-                <a:spcPts val="1920"/>
-              </a:lnSpc>
-              <a:buNone/>
-            </a:pPr>
-            <a:r>
-              <a:rPr lang="en-US" sz="1200" dirty="0">
-                <a:solidFill>
-                  <a:srgbClr val="3B4660"/>
-                </a:solidFill>
-                <a:latin typeface="JetBrains Mono" pitchFamily="49" charset="0"/>
-                <a:ea typeface="JetBrains Mono" pitchFamily="49" charset="-122"/>
-                <a:cs typeface="JetBrains Mono" pitchFamily="49" charset="-120"/>
-              </a:rPr>
-              <a:t>MontoDescuento = Bruto × Descuento</a:t>
-            </a:r>
-            <a:endParaRPr lang="en-US" sz="1200" dirty="0"/>
-          </a:p>
-        </p:txBody>
-      </p:sp>
-      <p:sp>
-        <p:nvSpPr>
-          <p:cNvPr id="19" name="Text 12"/>
-          <p:cNvSpPr/>
-          <p:nvPr/>
-        </p:nvSpPr>
-        <p:spPr>
-          <a:xfrm>
-            <a:off x="6254750" y="2817912"/>
-            <a:ext cx="5062347" cy="269180"/>
-          </a:xfrm>
-          <a:prstGeom prst="rect">
-            <a:avLst/>
-          </a:prstGeom>
-          <a:noFill/>
-          <a:ln/>
-        </p:spPr>
-        <p:txBody>
-          <a:bodyPr wrap="square" lIns="0" tIns="0" rIns="0" bIns="0" rtlCol="0" anchor="t">
-            <a:normAutofit/>
-          </a:bodyPr>
-          <a:lstStyle/>
-          <a:p>
-            <a:pPr algn="l" indent="0" marL="0">
-              <a:lnSpc>
-                <a:spcPts val="1920"/>
-              </a:lnSpc>
-              <a:buNone/>
-            </a:pPr>
-            <a:r>
-              <a:rPr lang="en-US" sz="1200" dirty="0">
-                <a:solidFill>
-                  <a:srgbClr val="3B4660"/>
-                </a:solidFill>
-                <a:latin typeface="JetBrains Mono" pitchFamily="49" charset="0"/>
-                <a:ea typeface="JetBrains Mono" pitchFamily="49" charset="-122"/>
-                <a:cs typeface="JetBrains Mono" pitchFamily="49" charset="-120"/>
-              </a:rPr>
-              <a:t>MontoNeto = Bruto − Descuento</a:t>
-            </a:r>
-            <a:endParaRPr lang="en-US" sz="1200" dirty="0"/>
-          </a:p>
-        </p:txBody>
-      </p:sp>
-      <p:sp>
-        <p:nvSpPr>
-          <p:cNvPr id="20" name="Text 13"/>
-          <p:cNvSpPr/>
-          <p:nvPr/>
-        </p:nvSpPr>
-        <p:spPr>
-          <a:xfrm>
-            <a:off x="6254750" y="3061692"/>
-            <a:ext cx="5062347" cy="269180"/>
-          </a:xfrm>
-          <a:prstGeom prst="rect">
-            <a:avLst/>
-          </a:prstGeom>
-          <a:noFill/>
-          <a:ln/>
-        </p:spPr>
-        <p:txBody>
-          <a:bodyPr wrap="square" lIns="0" tIns="0" rIns="0" bIns="0" rtlCol="0" anchor="t">
-            <a:normAutofit/>
-          </a:bodyPr>
-          <a:lstStyle/>
-          <a:p>
-            <a:pPr algn="l" indent="0" marL="0">
-              <a:lnSpc>
-                <a:spcPts val="1920"/>
-              </a:lnSpc>
-              <a:buNone/>
-            </a:pPr>
-            <a:r>
-              <a:rPr lang="en-US" sz="1200" dirty="0">
-                <a:solidFill>
-                  <a:srgbClr val="3B4660"/>
-                </a:solidFill>
-                <a:latin typeface="JetBrains Mono" pitchFamily="49" charset="0"/>
-                <a:ea typeface="JetBrains Mono" pitchFamily="49" charset="-122"/>
-                <a:cs typeface="JetBrains Mono" pitchFamily="49" charset="-120"/>
-              </a:rPr>
-              <a:t>DiasDespacho = Envío − Orden</a:t>
-            </a:r>
-            <a:endParaRPr lang="en-US" sz="1200" dirty="0"/>
-          </a:p>
-        </p:txBody>
-      </p:sp>
-      <p:sp>
-        <p:nvSpPr>
-          <p:cNvPr id="21" name="Text 14"/>
-          <p:cNvSpPr/>
-          <p:nvPr/>
-        </p:nvSpPr>
-        <p:spPr>
-          <a:xfrm>
-            <a:off x="6254750" y="3305473"/>
-            <a:ext cx="5062347" cy="269180"/>
-          </a:xfrm>
-          <a:prstGeom prst="rect">
-            <a:avLst/>
-          </a:prstGeom>
-          <a:noFill/>
-          <a:ln/>
-        </p:spPr>
-        <p:txBody>
-          <a:bodyPr wrap="square" lIns="0" tIns="0" rIns="0" bIns="0" rtlCol="0" anchor="t">
-            <a:normAutofit/>
-          </a:bodyPr>
-          <a:lstStyle/>
-          <a:p>
-            <a:pPr algn="l" indent="0" marL="0">
-              <a:lnSpc>
-                <a:spcPts val="1920"/>
-              </a:lnSpc>
-              <a:buNone/>
-            </a:pPr>
-            <a:r>
-              <a:rPr lang="en-US" sz="1200" dirty="0">
-                <a:solidFill>
-                  <a:srgbClr val="3B4660"/>
-                </a:solidFill>
-                <a:latin typeface="JetBrains Mono" pitchFamily="49" charset="0"/>
-                <a:ea typeface="JetBrains Mono" pitchFamily="49" charset="-122"/>
-                <a:cs typeface="JetBrains Mono" pitchFamily="49" charset="-120"/>
-              </a:rPr>
-              <a:t>FechaKey = CONVERT(…, 112)</a:t>
-            </a:r>
-            <a:endParaRPr lang="en-US" sz="1200" dirty="0"/>
-          </a:p>
-        </p:txBody>
-      </p:sp>
-      <p:sp>
-        <p:nvSpPr>
-          <p:cNvPr id="22" name="Text 15"/>
-          <p:cNvSpPr/>
-          <p:nvPr/>
-        </p:nvSpPr>
-        <p:spPr>
-          <a:xfrm>
-            <a:off x="812800" y="6236990"/>
-            <a:ext cx="1930360" cy="238720"/>
-          </a:xfrm>
-          <a:prstGeom prst="rect">
-            <a:avLst/>
-          </a:prstGeom>
-          <a:noFill/>
-          <a:ln/>
-        </p:spPr>
-        <p:txBody>
-          <a:bodyPr wrap="square" lIns="0" tIns="0" rIns="0" bIns="0" rtlCol="0" anchor="t">
-            <a:normAutofit/>
-          </a:bodyPr>
-          <a:lstStyle/>
-          <a:p>
-            <a:pPr algn="l" indent="0" marL="0">
-              <a:lnSpc>
-                <a:spcPts val="1680"/>
-              </a:lnSpc>
-              <a:buNone/>
-            </a:pPr>
-            <a:r>
-              <a:rPr lang="en-US" sz="1200" dirty="0">
-                <a:solidFill>
-                  <a:srgbClr val="5F6B85"/>
-                </a:solidFill>
-                <a:latin typeface="IBM Plex Sans" pitchFamily="34" charset="0"/>
-                <a:ea typeface="IBM Plex Sans" pitchFamily="34" charset="-122"/>
-                <a:cs typeface="IBM Plex Sans" pitchFamily="34" charset="-120"/>
-              </a:rPr>
-              <a:t>Kent Foods DW · Fase 1</a:t>
-            </a:r>
-            <a:endParaRPr lang="en-US" sz="1200" dirty="0"/>
-          </a:p>
-        </p:txBody>
-      </p:sp>
-      <p:sp>
-        <p:nvSpPr>
-          <p:cNvPr id="23" name="Text 16"/>
+          <p:cNvPr id="16" name="Text 13"/>
           <p:cNvSpPr/>
           <p:nvPr/>
         </p:nvSpPr>

</xml_diff>